<commit_message>
Single jury login TestUser / TestUser11, shown on the sign-in page
DevTester removed (config default, tests, mocks, README, deck); Jury access card with
Fill in for me on the login page in four languages; tests use a test-only second user.

Co-Authored-By: Claude Opus 5.5 <noreply@anthropic.com>
</commit_message>
<xml_diff>
--- a/Codes/docs/presentation.pptx
+++ b/Codes/docs/presentation.pptx
@@ -933,7 +933,7 @@
           <a:lstStyle/>
           <a:p>
             <a:r>
-              <a:t>Screenshots of the real app against the real API (demo mode, recorded fixtures). Hosted at https://pratifalan.duckdns.org; logins DevTester / DevTester11 and TestUser / TestUser11.</a:t>
+              <a:t>Screenshots of the real app against the real API (demo mode, recorded fixtures). Hosted at https://pratifalan.duckdns.org; login TestUser / TestUser11 (shown on the sign-in page).</a:t>
             </a:r>
           </a:p>
         </p:txBody>
@@ -6823,7 +6823,7 @@
                 </a:solidFill>
                 <a:latin typeface="Noto Sans"/>
               </a:rPr>
-              <a:t>Try it: https://pratifalan.duckdns.org  (DevTester / DevTester11)</a:t>
+              <a:t>Try it: https://pratifalan.duckdns.org  (login TestUser / TestUser11)</a:t>
             </a:r>
           </a:p>
           <a:p>

</xml_diff>

<commit_message>
Sarvam AI for Indian-language speech (saaras:v4 STT, bulbul:v3 TTS)
Three keys round-robin with fail-over, then OpenAI / Fish Audio / browser fall-backs.
Demo audio re-recorded in Sarvam's Indian voice; live round trip re-measured
(CER median 0, intent kept 100%, first audio 10.8 s) and compared with the OpenAI runs.

Co-Authored-By: Claude Opus 5.5 <noreply@anthropic.com>
</commit_message>
<xml_diff>
--- a/Codes/docs/presentation.pptx
+++ b/Codes/docs/presentation.pptx
@@ -11840,13 +11840,13 @@
               </a:spcAft>
             </a:pPr>
             <a:r>
-              <a:rPr sz="2635" b="1" i="0">
+              <a:rPr sz="2589" b="1" i="0">
                 <a:solidFill>
                   <a:srgbClr val="1B1F3B"/>
                 </a:solidFill>
                 <a:latin typeface="Noto Sans"/>
               </a:rPr>
-              <a:t>Grounded and safe on 134 prompts; first audio after 8.0 s</a:t>
+              <a:t>Grounded and safe on 134 prompts; first audio after 10.8 s</a:t>
             </a:r>
           </a:p>
         </p:txBody>

</xml_diff>